<commit_message>
code refactoring with ch0x
</commit_message>
<xml_diff>
--- a/ppt/RAG03-RAG.pptx
+++ b/ppt/RAG03-RAG.pptx
@@ -5,19 +5,21 @@
     <p:sldMasterId id="2147483653" r:id="rId1"/>
   </p:sldMasterIdLst>
   <p:notesMasterIdLst>
-    <p:notesMasterId r:id="rId9"/>
+    <p:notesMasterId r:id="rId11"/>
   </p:notesMasterIdLst>
   <p:handoutMasterIdLst>
-    <p:handoutMasterId r:id="rId10"/>
+    <p:handoutMasterId r:id="rId12"/>
   </p:handoutMasterIdLst>
   <p:sldIdLst>
     <p:sldId id="264" r:id="rId2"/>
     <p:sldId id="265" r:id="rId3"/>
     <p:sldId id="266" r:id="rId4"/>
-    <p:sldId id="267" r:id="rId5"/>
-    <p:sldId id="277" r:id="rId6"/>
-    <p:sldId id="268" r:id="rId7"/>
-    <p:sldId id="276" r:id="rId8"/>
+    <p:sldId id="286" r:id="rId5"/>
+    <p:sldId id="287" r:id="rId6"/>
+    <p:sldId id="267" r:id="rId7"/>
+    <p:sldId id="277" r:id="rId8"/>
+    <p:sldId id="268" r:id="rId9"/>
+    <p:sldId id="276" r:id="rId10"/>
   </p:sldIdLst>
   <p:sldSz cx="9144000" cy="6858000" type="screen4x3"/>
   <p:notesSz cx="6648450" cy="9782175"/>
@@ -4012,6 +4014,237 @@
           <p:cNvPr id="2" name="Titre 1">
             <a:extLst>
               <a:ext uri="{FF2B5EF4-FFF2-40B4-BE49-F238E27FC236}">
+                <a16:creationId xmlns:a16="http://schemas.microsoft.com/office/drawing/2014/main" id="{FC9E766A-D7EB-8753-5BF7-41F5DAD3BE30}"/>
+              </a:ext>
+            </a:extLst>
+          </p:cNvPr>
+          <p:cNvSpPr>
+            <a:spLocks noGrp="1"/>
+          </p:cNvSpPr>
+          <p:nvPr>
+            <p:ph type="title"/>
+          </p:nvPr>
+        </p:nvSpPr>
+        <p:spPr/>
+        <p:txBody>
+          <a:bodyPr/>
+          <a:lstStyle/>
+          <a:p>
+            <a:endParaRPr lang="fr-FR"/>
+          </a:p>
+        </p:txBody>
+      </p:sp>
+      <p:pic>
+        <p:nvPicPr>
+          <p:cNvPr id="1026" name="Picture 2" descr="index_diagram">
+            <a:extLst>
+              <a:ext uri="{FF2B5EF4-FFF2-40B4-BE49-F238E27FC236}">
+                <a16:creationId xmlns:a16="http://schemas.microsoft.com/office/drawing/2014/main" id="{E97727BE-F777-EEDA-FD92-C4E4497C0F17}"/>
+              </a:ext>
+            </a:extLst>
+          </p:cNvPr>
+          <p:cNvPicPr>
+            <a:picLocks noGrp="1" noChangeAspect="1" noChangeArrowheads="1"/>
+          </p:cNvPicPr>
+          <p:nvPr>
+            <p:ph idx="1"/>
+          </p:nvPr>
+        </p:nvPicPr>
+        <p:blipFill>
+          <a:blip r:embed="rId2" cstate="print">
+            <a:extLst>
+              <a:ext uri="{28A0092B-C50C-407E-A947-70E740481C1C}">
+                <a14:useLocalDpi xmlns:a14="http://schemas.microsoft.com/office/drawing/2010/main" val="0"/>
+              </a:ext>
+            </a:extLst>
+          </a:blip>
+          <a:srcRect/>
+          <a:stretch>
+            <a:fillRect/>
+          </a:stretch>
+        </p:blipFill>
+        <p:spPr bwMode="auto">
+          <a:xfrm>
+            <a:off x="179388" y="1728761"/>
+            <a:ext cx="8766175" cy="4408540"/>
+          </a:xfrm>
+          <a:prstGeom prst="rect">
+            <a:avLst/>
+          </a:prstGeom>
+          <a:noFill/>
+          <a:extLst>
+            <a:ext uri="{909E8E84-426E-40DD-AFC4-6F175D3DCCD1}">
+              <a14:hiddenFill xmlns:a14="http://schemas.microsoft.com/office/drawing/2010/main">
+                <a:solidFill>
+                  <a:srgbClr val="FFFFFF"/>
+                </a:solidFill>
+              </a14:hiddenFill>
+            </a:ext>
+          </a:extLst>
+        </p:spPr>
+      </p:pic>
+    </p:spTree>
+    <p:extLst>
+      <p:ext uri="{BB962C8B-B14F-4D97-AF65-F5344CB8AC3E}">
+        <p14:creationId xmlns:p14="http://schemas.microsoft.com/office/powerpoint/2010/main" val="1727230546"/>
+      </p:ext>
+    </p:extLst>
+  </p:cSld>
+  <p:clrMapOvr>
+    <a:masterClrMapping/>
+  </p:clrMapOvr>
+</p:sld>
+</file>
+
+<file path=ppt/slides/slide5.xml><?xml version="1.0" encoding="utf-8"?>
+<p:sld xmlns:a="http://schemas.openxmlformats.org/drawingml/2006/main" xmlns:r="http://schemas.openxmlformats.org/officeDocument/2006/relationships" xmlns:p="http://schemas.openxmlformats.org/presentationml/2006/main">
+  <p:cSld>
+    <p:spTree>
+      <p:nvGrpSpPr>
+        <p:cNvPr id="1" name=""/>
+        <p:cNvGrpSpPr/>
+        <p:nvPr/>
+      </p:nvGrpSpPr>
+      <p:grpSpPr>
+        <a:xfrm>
+          <a:off x="0" y="0"/>
+          <a:ext cx="0" cy="0"/>
+          <a:chOff x="0" y="0"/>
+          <a:chExt cx="0" cy="0"/>
+        </a:xfrm>
+      </p:grpSpPr>
+      <p:sp>
+        <p:nvSpPr>
+          <p:cNvPr id="2" name="Titre 1">
+            <a:extLst>
+              <a:ext uri="{FF2B5EF4-FFF2-40B4-BE49-F238E27FC236}">
+                <a16:creationId xmlns:a16="http://schemas.microsoft.com/office/drawing/2014/main" id="{10B398C0-CFE9-352D-F9ED-CA3EE8AC95F4}"/>
+              </a:ext>
+            </a:extLst>
+          </p:cNvPr>
+          <p:cNvSpPr>
+            <a:spLocks noGrp="1"/>
+          </p:cNvSpPr>
+          <p:nvPr>
+            <p:ph type="title"/>
+          </p:nvPr>
+        </p:nvSpPr>
+        <p:spPr/>
+        <p:txBody>
+          <a:bodyPr/>
+          <a:lstStyle/>
+          <a:p>
+            <a:endParaRPr lang="fr-FR"/>
+          </a:p>
+        </p:txBody>
+      </p:sp>
+      <p:sp>
+        <p:nvSpPr>
+          <p:cNvPr id="3" name="Espace réservé du contenu 2">
+            <a:extLst>
+              <a:ext uri="{FF2B5EF4-FFF2-40B4-BE49-F238E27FC236}">
+                <a16:creationId xmlns:a16="http://schemas.microsoft.com/office/drawing/2014/main" id="{6ABDD323-629B-5404-85C8-3CD3D0E3402F}"/>
+              </a:ext>
+            </a:extLst>
+          </p:cNvPr>
+          <p:cNvSpPr>
+            <a:spLocks noGrp="1"/>
+          </p:cNvSpPr>
+          <p:nvPr>
+            <p:ph idx="1"/>
+          </p:nvPr>
+        </p:nvSpPr>
+        <p:spPr/>
+        <p:txBody>
+          <a:bodyPr/>
+          <a:lstStyle/>
+          <a:p>
+            <a:endParaRPr lang="fr-FR"/>
+          </a:p>
+        </p:txBody>
+      </p:sp>
+      <p:pic>
+        <p:nvPicPr>
+          <p:cNvPr id="1026" name="Picture 2" descr="retrieval_diagram">
+            <a:extLst>
+              <a:ext uri="{FF2B5EF4-FFF2-40B4-BE49-F238E27FC236}">
+                <a16:creationId xmlns:a16="http://schemas.microsoft.com/office/drawing/2014/main" id="{AE830D2C-C82D-4590-43C4-4C8B75CEC73A}"/>
+              </a:ext>
+            </a:extLst>
+          </p:cNvPr>
+          <p:cNvPicPr>
+            <a:picLocks noChangeAspect="1" noChangeArrowheads="1"/>
+          </p:cNvPicPr>
+          <p:nvPr/>
+        </p:nvPicPr>
+        <p:blipFill>
+          <a:blip r:embed="rId2" cstate="print">
+            <a:extLst>
+              <a:ext uri="{28A0092B-C50C-407E-A947-70E740481C1C}">
+                <a14:useLocalDpi xmlns:a14="http://schemas.microsoft.com/office/drawing/2010/main" val="0"/>
+              </a:ext>
+            </a:extLst>
+          </a:blip>
+          <a:srcRect/>
+          <a:stretch>
+            <a:fillRect/>
+          </a:stretch>
+        </p:blipFill>
+        <p:spPr bwMode="auto">
+          <a:xfrm>
+            <a:off x="0" y="1082675"/>
+            <a:ext cx="9144000" cy="4691063"/>
+          </a:xfrm>
+          <a:prstGeom prst="rect">
+            <a:avLst/>
+          </a:prstGeom>
+          <a:noFill/>
+          <a:extLst>
+            <a:ext uri="{909E8E84-426E-40DD-AFC4-6F175D3DCCD1}">
+              <a14:hiddenFill xmlns:a14="http://schemas.microsoft.com/office/drawing/2010/main">
+                <a:solidFill>
+                  <a:srgbClr val="FFFFFF"/>
+                </a:solidFill>
+              </a14:hiddenFill>
+            </a:ext>
+          </a:extLst>
+        </p:spPr>
+      </p:pic>
+    </p:spTree>
+    <p:extLst>
+      <p:ext uri="{BB962C8B-B14F-4D97-AF65-F5344CB8AC3E}">
+        <p14:creationId xmlns:p14="http://schemas.microsoft.com/office/powerpoint/2010/main" val="2838637778"/>
+      </p:ext>
+    </p:extLst>
+  </p:cSld>
+  <p:clrMapOvr>
+    <a:masterClrMapping/>
+  </p:clrMapOvr>
+</p:sld>
+</file>
+
+<file path=ppt/slides/slide6.xml><?xml version="1.0" encoding="utf-8"?>
+<p:sld xmlns:a="http://schemas.openxmlformats.org/drawingml/2006/main" xmlns:r="http://schemas.openxmlformats.org/officeDocument/2006/relationships" xmlns:p="http://schemas.openxmlformats.org/presentationml/2006/main">
+  <p:cSld>
+    <p:spTree>
+      <p:nvGrpSpPr>
+        <p:cNvPr id="1" name=""/>
+        <p:cNvGrpSpPr/>
+        <p:nvPr/>
+      </p:nvGrpSpPr>
+      <p:grpSpPr>
+        <a:xfrm>
+          <a:off x="0" y="0"/>
+          <a:ext cx="0" cy="0"/>
+          <a:chOff x="0" y="0"/>
+          <a:chExt cx="0" cy="0"/>
+        </a:xfrm>
+      </p:grpSpPr>
+      <p:sp>
+        <p:nvSpPr>
+          <p:cNvPr id="2" name="Titre 1">
+            <a:extLst>
+              <a:ext uri="{FF2B5EF4-FFF2-40B4-BE49-F238E27FC236}">
                 <a16:creationId xmlns:a16="http://schemas.microsoft.com/office/drawing/2014/main" id="{01EF1CA9-48A4-1270-8CE8-2AAEB2DF3816}"/>
               </a:ext>
             </a:extLst>
@@ -4156,7 +4389,7 @@
 </p:sld>
 </file>
 
-<file path=ppt/slides/slide5.xml><?xml version="1.0" encoding="utf-8"?>
+<file path=ppt/slides/slide7.xml><?xml version="1.0" encoding="utf-8"?>
 <p:sld xmlns:a="http://schemas.openxmlformats.org/drawingml/2006/main" xmlns:r="http://schemas.openxmlformats.org/officeDocument/2006/relationships" xmlns:p="http://schemas.openxmlformats.org/presentationml/2006/main">
   <p:cSld>
     <p:spTree>
@@ -4271,7 +4504,7 @@
 </p:sld>
 </file>
 
-<file path=ppt/slides/slide6.xml><?xml version="1.0" encoding="utf-8"?>
+<file path=ppt/slides/slide8.xml><?xml version="1.0" encoding="utf-8"?>
 <p:sld xmlns:a="http://schemas.openxmlformats.org/drawingml/2006/main" xmlns:r="http://schemas.openxmlformats.org/officeDocument/2006/relationships" xmlns:p="http://schemas.openxmlformats.org/presentationml/2006/main">
   <p:cSld>
     <p:spTree>
@@ -4433,7 +4666,7 @@
 </p:sld>
 </file>
 
-<file path=ppt/slides/slide7.xml><?xml version="1.0" encoding="utf-8"?>
+<file path=ppt/slides/slide9.xml><?xml version="1.0" encoding="utf-8"?>
 <p:sld xmlns:a="http://schemas.openxmlformats.org/drawingml/2006/main" xmlns:r="http://schemas.openxmlformats.org/officeDocument/2006/relationships" xmlns:p="http://schemas.openxmlformats.org/presentationml/2006/main">
   <p:cSld>
     <p:spTree>

</xml_diff>